<commit_message>
docs(mkof): GitHub Paso 2 — repo privado mova-n8n-workflows
- Guía HTML con 10 pasos, capturas y checklist
- PPT y PDF MOVA-GitHub-Paso2-Repo-Privado
- Hub documentos, landing MKOF y enlace desde Paso 1
- Scripts captura, PDF y PPT para Paso 2

Co-authored-by: JosefaOgalde <JosefaOgalde@users.noreply.github.com>
</commit_message>
<xml_diff>
--- a/index/clientes/mkof/MOVA-GitHub-Paso1-Crear-Cuenta.pptx
+++ b/index/clientes/mkof/MOVA-GitHub-Paso1-Crear-Cuenta.pptx
@@ -5931,7 +5931,7 @@
               </a:defRPr>
             </a:pPr>
             <a:r>
-              <a:t>Paso 2 · Próxima entrega</a:t>
+              <a:t>Paso 2 · Continuación disponible</a:t>
             </a:r>
           </a:p>
         </p:txBody>
@@ -6006,7 +6006,7 @@
               </a:defRPr>
             </a:pPr>
             <a:r>
-              <a:t>Cuando la cuenta esté lista, avisar al equipo para recibir la guía del Paso 2.</a:t>
+              <a:t>Guía: github-repo.html · PPT: MOVA-GitHub-Paso2-Repo-Privado.pptx</a:t>
             </a:r>
           </a:p>
         </p:txBody>

</xml_diff>